<commit_message>
feat: export deck to PDF and validate rendering
The structural lint cannot see rendering defects. Exporting to PDF caught
literal markup, an overflowing figure label and an arrow crossing a caption,
all now fixed, plus inline bold and code formatting.
</commit_message>
<xml_diff>
--- a/slides/saida/aula-1.pptx
+++ b/slides/saida/aula-1.pptx
@@ -6010,7 +6010,25 @@
                 </a:solidFill>
                 <a:latin typeface="Segoe UI"/>
               </a:rPr>
-              <a:t>—  **Alucinação** — gera o plausível, não o verdadeiro</a:t>
+              <a:t>—  </a:t>
+            </a:r>
+            <a:r>
+              <a:rPr sz="1900" b="1" i="0">
+                <a:solidFill>
+                  <a:srgbClr val="16181D"/>
+                </a:solidFill>
+                <a:latin typeface="Segoe UI"/>
+              </a:rPr>
+              <a:t>Alucinação</a:t>
+            </a:r>
+            <a:r>
+              <a:rPr sz="1900" b="0" i="0">
+                <a:solidFill>
+                  <a:srgbClr val="16181D"/>
+                </a:solidFill>
+                <a:latin typeface="Segoe UI"/>
+              </a:rPr>
+              <a:t> — gera o plausível, não o verdadeiro</a:t>
             </a:r>
           </a:p>
           <a:p>
@@ -6032,7 +6050,25 @@
                 </a:solidFill>
                 <a:latin typeface="Segoe UI"/>
               </a:rPr>
-              <a:t>—  **Data de corte** — não conhece o que veio depois do treinamento</a:t>
+              <a:t>—  </a:t>
+            </a:r>
+            <a:r>
+              <a:rPr sz="1900" b="1" i="0">
+                <a:solidFill>
+                  <a:srgbClr val="16181D"/>
+                </a:solidFill>
+                <a:latin typeface="Segoe UI"/>
+              </a:rPr>
+              <a:t>Data de corte</a:t>
+            </a:r>
+            <a:r>
+              <a:rPr sz="1900" b="0" i="0">
+                <a:solidFill>
+                  <a:srgbClr val="16181D"/>
+                </a:solidFill>
+                <a:latin typeface="Segoe UI"/>
+              </a:rPr>
+              <a:t> — não conhece o que veio depois do treinamento</a:t>
             </a:r>
           </a:p>
           <a:p>
@@ -6054,7 +6090,25 @@
                 </a:solidFill>
                 <a:latin typeface="Segoe UI"/>
               </a:rPr>
-              <a:t>—  **Ausência de estado** — cada requisição começa do zero</a:t>
+              <a:t>—  </a:t>
+            </a:r>
+            <a:r>
+              <a:rPr sz="1900" b="1" i="0">
+                <a:solidFill>
+                  <a:srgbClr val="16181D"/>
+                </a:solidFill>
+                <a:latin typeface="Segoe UI"/>
+              </a:rPr>
+              <a:t>Ausência de estado</a:t>
+            </a:r>
+            <a:r>
+              <a:rPr sz="1900" b="0" i="0">
+                <a:solidFill>
+                  <a:srgbClr val="16181D"/>
+                </a:solidFill>
+                <a:latin typeface="Segoe UI"/>
+              </a:rPr>
+              <a:t> — cada requisição começa do zero</a:t>
             </a:r>
           </a:p>
           <a:p>
@@ -6704,8 +6758,8 @@
         </p:nvSpPr>
         <p:spPr>
           <a:xfrm>
-            <a:off x="868680" y="5961888"/>
-            <a:ext cx="10454335" cy="274320"/>
+            <a:off x="1357689" y="5998464"/>
+            <a:ext cx="9476315" cy="274320"/>
           </a:xfrm>
           <a:prstGeom prst="rect">
             <a:avLst/>
@@ -7008,7 +7062,25 @@
                 </a:solidFill>
                 <a:latin typeface="Segoe UI"/>
               </a:rPr>
-              <a:t>—  Não é "quanto ele lembra": é quanto cabe **nesta** requisição</a:t>
+              <a:t>—  Não é "quanto ele lembra": é quanto cabe </a:t>
+            </a:r>
+            <a:r>
+              <a:rPr sz="1900" b="1" i="0">
+                <a:solidFill>
+                  <a:srgbClr val="16181D"/>
+                </a:solidFill>
+                <a:latin typeface="Segoe UI"/>
+              </a:rPr>
+              <a:t>nesta</a:t>
+            </a:r>
+            <a:r>
+              <a:rPr sz="1900" b="0" i="0">
+                <a:solidFill>
+                  <a:srgbClr val="16181D"/>
+                </a:solidFill>
+                <a:latin typeface="Segoe UI"/>
+              </a:rPr>
+              <a:t> requisição</a:t>
             </a:r>
           </a:p>
           <a:p>
@@ -7316,8 +7388,8 @@
         </p:nvSpPr>
         <p:spPr>
           <a:xfrm>
-            <a:off x="868680" y="5961888"/>
-            <a:ext cx="10454335" cy="274320"/>
+            <a:off x="1375145" y="5998464"/>
+            <a:ext cx="9441403" cy="274320"/>
           </a:xfrm>
           <a:prstGeom prst="rect">
             <a:avLst/>
@@ -7567,7 +7639,7 @@
         <p:spPr>
           <a:xfrm>
             <a:off x="868680" y="1609343"/>
-            <a:ext cx="3744047" cy="4562856"/>
+            <a:ext cx="4162220" cy="4562856"/>
           </a:xfrm>
           <a:prstGeom prst="rect">
             <a:avLst/>
@@ -7598,7 +7670,25 @@
                 </a:solidFill>
                 <a:latin typeface="Segoe UI"/>
               </a:rPr>
-              <a:t>—  **Prompt caching** — o prefixo repetido é cacheado e sai muito mais barato que a primeira vez</a:t>
+              <a:t>—  </a:t>
+            </a:r>
+            <a:r>
+              <a:rPr sz="1900" b="1" i="0">
+                <a:solidFill>
+                  <a:srgbClr val="16181D"/>
+                </a:solidFill>
+                <a:latin typeface="Segoe UI"/>
+              </a:rPr>
+              <a:t>Prompt caching</a:t>
+            </a:r>
+            <a:r>
+              <a:rPr sz="1900" b="0" i="0">
+                <a:solidFill>
+                  <a:srgbClr val="16181D"/>
+                </a:solidFill>
+                <a:latin typeface="Segoe UI"/>
+              </a:rPr>
+              <a:t> — o prefixo repetido é cacheado e sai muito mais barato que a primeira vez</a:t>
             </a:r>
           </a:p>
           <a:p>
@@ -7664,7 +7754,25 @@
                 </a:solidFill>
                 <a:latin typeface="Segoe UI"/>
               </a:rPr>
-              <a:t>—  **Compaction** — quando a janela satura, a conversa é resumida e recomeça</a:t>
+              <a:t>—  </a:t>
+            </a:r>
+            <a:r>
+              <a:rPr sz="1900" b="1" i="0">
+                <a:solidFill>
+                  <a:srgbClr val="16181D"/>
+                </a:solidFill>
+                <a:latin typeface="Segoe UI"/>
+              </a:rPr>
+              <a:t>Compaction</a:t>
+            </a:r>
+            <a:r>
+              <a:rPr sz="1900" b="0" i="0">
+                <a:solidFill>
+                  <a:srgbClr val="16181D"/>
+                </a:solidFill>
+                <a:latin typeface="Segoe UI"/>
+              </a:rPr>
+              <a:t> — quando a janela satura, a conversa é resumida e recomeça</a:t>
             </a:r>
           </a:p>
         </p:txBody>
@@ -7685,8 +7793,8 @@
         </p:blipFill>
         <p:spPr>
           <a:xfrm>
-            <a:off x="4841327" y="2459099"/>
-            <a:ext cx="6481687" cy="2634745"/>
+            <a:off x="5259500" y="2544091"/>
+            <a:ext cx="6063514" cy="2464761"/>
           </a:xfrm>
           <a:prstGeom prst="rect">
             <a:avLst/>
@@ -7701,8 +7809,8 @@
         </p:nvSpPr>
         <p:spPr>
           <a:xfrm>
-            <a:off x="4841327" y="5961888"/>
-            <a:ext cx="6481687" cy="274320"/>
+            <a:off x="5259500" y="5063716"/>
+            <a:ext cx="6063514" cy="274320"/>
           </a:xfrm>
           <a:prstGeom prst="rect">
             <a:avLst/>
@@ -7983,7 +8091,43 @@
                 </a:solidFill>
                 <a:latin typeface="Segoe UI"/>
               </a:rPr>
-              <a:t>—  **Contexto persistente**: `CLAUDE.md` no Code, Projects e memória no Chat</a:t>
+              <a:t>—  </a:t>
+            </a:r>
+            <a:r>
+              <a:rPr sz="1900" b="1" i="0">
+                <a:solidFill>
+                  <a:srgbClr val="16181D"/>
+                </a:solidFill>
+                <a:latin typeface="Segoe UI"/>
+              </a:rPr>
+              <a:t>Contexto persistente</a:t>
+            </a:r>
+            <a:r>
+              <a:rPr sz="1900" b="0" i="0">
+                <a:solidFill>
+                  <a:srgbClr val="16181D"/>
+                </a:solidFill>
+                <a:latin typeface="Segoe UI"/>
+              </a:rPr>
+              <a:t>: </a:t>
+            </a:r>
+            <a:r>
+              <a:rPr sz="1748" b="0" i="0">
+                <a:solidFill>
+                  <a:srgbClr val="16181D"/>
+                </a:solidFill>
+                <a:latin typeface="Consolas"/>
+              </a:rPr>
+              <a:t>CLAUDE.md</a:t>
+            </a:r>
+            <a:r>
+              <a:rPr sz="1900" b="0" i="0">
+                <a:solidFill>
+                  <a:srgbClr val="16181D"/>
+                </a:solidFill>
+                <a:latin typeface="Segoe UI"/>
+              </a:rPr>
+              <a:t> no Code, Projects e memória no Chat</a:t>
             </a:r>
           </a:p>
           <a:p>
@@ -8005,7 +8149,25 @@
                 </a:solidFill>
                 <a:latin typeface="Segoe UI"/>
               </a:rPr>
-              <a:t>—  Entra **sempre**, em toda requisição — ao contrário do material de apoio, que entra sob demanda</a:t>
+              <a:t>—  Entra </a:t>
+            </a:r>
+            <a:r>
+              <a:rPr sz="1900" b="1" i="0">
+                <a:solidFill>
+                  <a:srgbClr val="16181D"/>
+                </a:solidFill>
+                <a:latin typeface="Segoe UI"/>
+              </a:rPr>
+              <a:t>sempre</a:t>
+            </a:r>
+            <a:r>
+              <a:rPr sz="1900" b="0" i="0">
+                <a:solidFill>
+                  <a:srgbClr val="16181D"/>
+                </a:solidFill>
+                <a:latin typeface="Segoe UI"/>
+              </a:rPr>
+              <a:t>, em toda requisição — ao contrário do material de apoio, que entra sob demanda</a:t>
             </a:r>
           </a:p>
           <a:p>
@@ -8321,7 +8483,25 @@
                 </a:solidFill>
                 <a:latin typeface="Segoe UI"/>
               </a:rPr>
-              <a:t>—  **Modelo**: capacidade × latência × custo. Não existe escolha universalmente certa</a:t>
+              <a:t>—  </a:t>
+            </a:r>
+            <a:r>
+              <a:rPr sz="1900" b="1" i="0">
+                <a:solidFill>
+                  <a:srgbClr val="16181D"/>
+                </a:solidFill>
+                <a:latin typeface="Segoe UI"/>
+              </a:rPr>
+              <a:t>Modelo</a:t>
+            </a:r>
+            <a:r>
+              <a:rPr sz="1900" b="0" i="0">
+                <a:solidFill>
+                  <a:srgbClr val="16181D"/>
+                </a:solidFill>
+                <a:latin typeface="Segoe UI"/>
+              </a:rPr>
+              <a:t>: capacidade × latência × custo. Não existe escolha universalmente certa</a:t>
             </a:r>
           </a:p>
           <a:p>
@@ -8343,7 +8523,25 @@
                 </a:solidFill>
                 <a:latin typeface="Segoe UI"/>
               </a:rPr>
-              <a:t>—  **Thinking**: o modelo raciocina antes de responder — e esse raciocínio também são tokens</a:t>
+              <a:t>—  </a:t>
+            </a:r>
+            <a:r>
+              <a:rPr sz="1900" b="1" i="0">
+                <a:solidFill>
+                  <a:srgbClr val="16181D"/>
+                </a:solidFill>
+                <a:latin typeface="Segoe UI"/>
+              </a:rPr>
+              <a:t>Thinking</a:t>
+            </a:r>
+            <a:r>
+              <a:rPr sz="1900" b="0" i="0">
+                <a:solidFill>
+                  <a:srgbClr val="16181D"/>
+                </a:solidFill>
+                <a:latin typeface="Segoe UI"/>
+              </a:rPr>
+              <a:t>: o modelo raciocina antes de responder — e esse raciocínio também são tokens</a:t>
             </a:r>
           </a:p>
           <a:p>
@@ -8365,7 +8563,25 @@
                 </a:solidFill>
                 <a:latin typeface="Segoe UI"/>
               </a:rPr>
-              <a:t>—  **Effort**: quanto desse raciocínio investir</a:t>
+              <a:t>—  </a:t>
+            </a:r>
+            <a:r>
+              <a:rPr sz="1900" b="1" i="0">
+                <a:solidFill>
+                  <a:srgbClr val="16181D"/>
+                </a:solidFill>
+                <a:latin typeface="Segoe UI"/>
+              </a:rPr>
+              <a:t>Effort</a:t>
+            </a:r>
+            <a:r>
+              <a:rPr sz="1900" b="0" i="0">
+                <a:solidFill>
+                  <a:srgbClr val="16181D"/>
+                </a:solidFill>
+                <a:latin typeface="Segoe UI"/>
+              </a:rPr>
+              <a:t>: quanto desse raciocínio investir</a:t>
             </a:r>
           </a:p>
           <a:p>
@@ -8387,7 +8603,106 @@
                 </a:solidFill>
                 <a:latin typeface="Segoe UI"/>
               </a:rPr>
-              <a:t>·  níveis disponíveis: `low`, `medium`, `high`, `xhigh`, `max`; padrão `high`</a:t>
+              <a:t>·  níveis disponíveis: </a:t>
+            </a:r>
+            <a:r>
+              <a:rPr sz="1472" b="0" i="0">
+                <a:solidFill>
+                  <a:srgbClr val="6A6E76"/>
+                </a:solidFill>
+                <a:latin typeface="Consolas"/>
+              </a:rPr>
+              <a:t>low</a:t>
+            </a:r>
+            <a:r>
+              <a:rPr sz="1600" b="0" i="0">
+                <a:solidFill>
+                  <a:srgbClr val="6A6E76"/>
+                </a:solidFill>
+                <a:latin typeface="Segoe UI"/>
+              </a:rPr>
+              <a:t>, </a:t>
+            </a:r>
+            <a:r>
+              <a:rPr sz="1472" b="0" i="0">
+                <a:solidFill>
+                  <a:srgbClr val="6A6E76"/>
+                </a:solidFill>
+                <a:latin typeface="Consolas"/>
+              </a:rPr>
+              <a:t>medium</a:t>
+            </a:r>
+            <a:r>
+              <a:rPr sz="1600" b="0" i="0">
+                <a:solidFill>
+                  <a:srgbClr val="6A6E76"/>
+                </a:solidFill>
+                <a:latin typeface="Segoe UI"/>
+              </a:rPr>
+              <a:t>, </a:t>
+            </a:r>
+            <a:r>
+              <a:rPr sz="1472" b="0" i="0">
+                <a:solidFill>
+                  <a:srgbClr val="6A6E76"/>
+                </a:solidFill>
+                <a:latin typeface="Consolas"/>
+              </a:rPr>
+              <a:t>high</a:t>
+            </a:r>
+            <a:r>
+              <a:rPr sz="1600" b="0" i="0">
+                <a:solidFill>
+                  <a:srgbClr val="6A6E76"/>
+                </a:solidFill>
+                <a:latin typeface="Segoe UI"/>
+              </a:rPr>
+              <a:t>, </a:t>
+            </a:r>
+            <a:r>
+              <a:rPr sz="1472" b="0" i="0">
+                <a:solidFill>
+                  <a:srgbClr val="6A6E76"/>
+                </a:solidFill>
+                <a:latin typeface="Consolas"/>
+              </a:rPr>
+              <a:t>xhigh</a:t>
+            </a:r>
+            <a:r>
+              <a:rPr sz="1600" b="0" i="0">
+                <a:solidFill>
+                  <a:srgbClr val="6A6E76"/>
+                </a:solidFill>
+                <a:latin typeface="Segoe UI"/>
+              </a:rPr>
+              <a:t>, </a:t>
+            </a:r>
+            <a:r>
+              <a:rPr sz="1472" b="0" i="0">
+                <a:solidFill>
+                  <a:srgbClr val="6A6E76"/>
+                </a:solidFill>
+                <a:latin typeface="Consolas"/>
+              </a:rPr>
+              <a:t>max</a:t>
+            </a:r>
+            <a:r>
+              <a:rPr sz="1600" b="0" i="0">
+                <a:solidFill>
+                  <a:srgbClr val="6A6E76"/>
+                </a:solidFill>
+                <a:latin typeface="Segoe UI"/>
+              </a:rPr>
+              <a:t>; padrão </a:t>
+            </a:r>
+            <a:r>
+              <a:rPr sz="1472" b="0" i="0">
+                <a:solidFill>
+                  <a:srgbClr val="6A6E76"/>
+                </a:solidFill>
+                <a:latin typeface="Consolas"/>
+              </a:rPr>
+              <a:t>high</a:t>
             </a:r>
           </a:p>
           <a:p>
@@ -9405,7 +9720,25 @@
                 </a:solidFill>
                 <a:latin typeface="Segoe UI"/>
               </a:rPr>
-              <a:t>—  O modelo responde **pedindo** uma chamada; o cliente executa e devolve o resultado</a:t>
+              <a:t>—  O modelo responde </a:t>
+            </a:r>
+            <a:r>
+              <a:rPr sz="1900" b="1" i="0">
+                <a:solidFill>
+                  <a:srgbClr val="16181D"/>
+                </a:solidFill>
+                <a:latin typeface="Segoe UI"/>
+              </a:rPr>
+              <a:t>pedindo</a:t>
+            </a:r>
+            <a:r>
+              <a:rPr sz="1900" b="0" i="0">
+                <a:solidFill>
+                  <a:srgbClr val="16181D"/>
+                </a:solidFill>
+                <a:latin typeface="Segoe UI"/>
+              </a:rPr>
+              <a:t> uma chamada; o cliente executa e devolve o resultado</a:t>
             </a:r>
           </a:p>
           <a:p>
@@ -9691,8 +10024,8 @@
         </p:nvSpPr>
         <p:spPr>
           <a:xfrm>
-            <a:off x="868680" y="5961888"/>
-            <a:ext cx="10454335" cy="274320"/>
+            <a:off x="1926798" y="5998464"/>
+            <a:ext cx="8338097" cy="274320"/>
           </a:xfrm>
           <a:prstGeom prst="rect">
             <a:avLst/>
@@ -9995,7 +10328,25 @@
                 </a:solidFill>
                 <a:latin typeface="Segoe UI"/>
               </a:rPr>
-              <a:t>—  É um **papel**, não um produto — o mesmo papel aparece nos três produtos da próxima seção</a:t>
+              <a:t>—  É um </a:t>
+            </a:r>
+            <a:r>
+              <a:rPr sz="1900" b="1" i="0">
+                <a:solidFill>
+                  <a:srgbClr val="16181D"/>
+                </a:solidFill>
+                <a:latin typeface="Segoe UI"/>
+              </a:rPr>
+              <a:t>papel</a:t>
+            </a:r>
+            <a:r>
+              <a:rPr sz="1900" b="0" i="0">
+                <a:solidFill>
+                  <a:srgbClr val="16181D"/>
+                </a:solidFill>
+                <a:latin typeface="Segoe UI"/>
+              </a:rPr>
+              <a:t>, não um produto — o mesmo papel aparece nos três produtos da próxima seção</a:t>
             </a:r>
           </a:p>
           <a:p>
@@ -10017,7 +10368,25 @@
                 </a:solidFill>
                 <a:latin typeface="Segoe UI"/>
               </a:rPr>
-              <a:t>—  No Claude Code, esse papel é descrito em texto, no `CLAUDE.md` do projeto</a:t>
+              <a:t>—  No Claude Code, esse papel é descrito em texto, no </a:t>
+            </a:r>
+            <a:r>
+              <a:rPr sz="1748" b="0" i="0">
+                <a:solidFill>
+                  <a:srgbClr val="16181D"/>
+                </a:solidFill>
+                <a:latin typeface="Consolas"/>
+              </a:rPr>
+              <a:t>CLAUDE.md</a:t>
+            </a:r>
+            <a:r>
+              <a:rPr sz="1900" b="0" i="0">
+                <a:solidFill>
+                  <a:srgbClr val="16181D"/>
+                </a:solidFill>
+                <a:latin typeface="Segoe UI"/>
+              </a:rPr>
+              <a:t> do projeto</a:t>
             </a:r>
           </a:p>
           <a:p>
@@ -10303,8 +10672,8 @@
         </p:nvSpPr>
         <p:spPr>
           <a:xfrm>
-            <a:off x="868680" y="5961888"/>
-            <a:ext cx="10454335" cy="274320"/>
+            <a:off x="1508966" y="5998464"/>
+            <a:ext cx="9173762" cy="274320"/>
           </a:xfrm>
           <a:prstGeom prst="rect">
             <a:avLst/>
@@ -10577,8 +10946,8 @@
         </p:nvSpPr>
         <p:spPr>
           <a:xfrm>
-            <a:off x="868680" y="5961888"/>
-            <a:ext cx="10454335" cy="274320"/>
+            <a:off x="1640003" y="5998464"/>
+            <a:ext cx="8911688" cy="274320"/>
           </a:xfrm>
           <a:prstGeom prst="rect">
             <a:avLst/>
@@ -11215,8 +11584,8 @@
         </p:nvSpPr>
         <p:spPr>
           <a:xfrm>
-            <a:off x="868680" y="5961888"/>
-            <a:ext cx="10454335" cy="274320"/>
+            <a:off x="1418084" y="5998464"/>
+            <a:ext cx="9355526" cy="274320"/>
           </a:xfrm>
           <a:prstGeom prst="rect">
             <a:avLst/>
@@ -11497,7 +11866,25 @@
                 </a:solidFill>
                 <a:latin typeface="Segoe UI"/>
               </a:rPr>
-              <a:t>—  **Chat** — a porta de entrada do pesquisador</a:t>
+              <a:t>—  </a:t>
+            </a:r>
+            <a:r>
+              <a:rPr sz="1900" b="1" i="0">
+                <a:solidFill>
+                  <a:srgbClr val="16181D"/>
+                </a:solidFill>
+                <a:latin typeface="Segoe UI"/>
+              </a:rPr>
+              <a:t>Chat</a:t>
+            </a:r>
+            <a:r>
+              <a:rPr sz="1900" b="0" i="0">
+                <a:solidFill>
+                  <a:srgbClr val="16181D"/>
+                </a:solidFill>
+                <a:latin typeface="Segoe UI"/>
+              </a:rPr>
+              <a:t> — a porta de entrada do pesquisador</a:t>
             </a:r>
           </a:p>
           <a:p>
@@ -11563,7 +11950,25 @@
                 </a:solidFill>
                 <a:latin typeface="Segoe UI"/>
               </a:rPr>
-              <a:t>—  **Cowork** — trabalho delegado sobre arquivos e tarefas</a:t>
+              <a:t>—  </a:t>
+            </a:r>
+            <a:r>
+              <a:rPr sz="1900" b="1" i="0">
+                <a:solidFill>
+                  <a:srgbClr val="16181D"/>
+                </a:solidFill>
+                <a:latin typeface="Segoe UI"/>
+              </a:rPr>
+              <a:t>Cowork</a:t>
+            </a:r>
+            <a:r>
+              <a:rPr sz="1900" b="0" i="0">
+                <a:solidFill>
+                  <a:srgbClr val="16181D"/>
+                </a:solidFill>
+                <a:latin typeface="Segoe UI"/>
+              </a:rPr>
+              <a:t> — trabalho delegado sobre arquivos e tarefas</a:t>
             </a:r>
           </a:p>
           <a:p>
@@ -11872,8 +12277,8 @@
         </p:nvSpPr>
         <p:spPr>
           <a:xfrm>
-            <a:off x="868680" y="5961888"/>
-            <a:ext cx="10454335" cy="274320"/>
+            <a:off x="2547423" y="5998464"/>
+            <a:ext cx="7096849" cy="274320"/>
           </a:xfrm>
           <a:prstGeom prst="rect">
             <a:avLst/>
@@ -12154,7 +12559,25 @@
                 </a:solidFill>
                 <a:latin typeface="Segoe UI"/>
               </a:rPr>
-              <a:t>—  **Code** — o agente dentro do repositório</a:t>
+              <a:t>—  </a:t>
+            </a:r>
+            <a:r>
+              <a:rPr sz="1900" b="1" i="0">
+                <a:solidFill>
+                  <a:srgbClr val="16181D"/>
+                </a:solidFill>
+                <a:latin typeface="Segoe UI"/>
+              </a:rPr>
+              <a:t>Code</a:t>
+            </a:r>
+            <a:r>
+              <a:rPr sz="1900" b="0" i="0">
+                <a:solidFill>
+                  <a:srgbClr val="16181D"/>
+                </a:solidFill>
+                <a:latin typeface="Segoe UI"/>
+              </a:rPr>
+              <a:t> — o agente dentro do repositório</a:t>
             </a:r>
           </a:p>
           <a:p>
@@ -12176,7 +12599,25 @@
                 </a:solidFill>
                 <a:latin typeface="Segoe UI"/>
               </a:rPr>
-              <a:t>·  `CLAUDE.md`, skills, material de apoio e subagents</a:t>
+              <a:t>·  </a:t>
+            </a:r>
+            <a:r>
+              <a:rPr sz="1472" b="0" i="0">
+                <a:solidFill>
+                  <a:srgbClr val="6A6E76"/>
+                </a:solidFill>
+                <a:latin typeface="Consolas"/>
+              </a:rPr>
+              <a:t>CLAUDE.md</a:t>
+            </a:r>
+            <a:r>
+              <a:rPr sz="1600" b="0" i="0">
+                <a:solidFill>
+                  <a:srgbClr val="6A6E76"/>
+                </a:solidFill>
+                <a:latin typeface="Segoe UI"/>
+              </a:rPr>
+              <a:t>, skills, material de apoio e subagents</a:t>
             </a:r>
           </a:p>
           <a:p>
@@ -12220,7 +12661,25 @@
                 </a:solidFill>
                 <a:latin typeface="Segoe UI"/>
               </a:rPr>
-              <a:t>—  **Hooks** — comando determinístico em torno de um núcleo estocástico</a:t>
+              <a:t>—  </a:t>
+            </a:r>
+            <a:r>
+              <a:rPr sz="1900" b="1" i="0">
+                <a:solidFill>
+                  <a:srgbClr val="16181D"/>
+                </a:solidFill>
+                <a:latin typeface="Segoe UI"/>
+              </a:rPr>
+              <a:t>Hooks</a:t>
+            </a:r>
+            <a:r>
+              <a:rPr sz="1900" b="0" i="0">
+                <a:solidFill>
+                  <a:srgbClr val="16181D"/>
+                </a:solidFill>
+                <a:latin typeface="Segoe UI"/>
+              </a:rPr>
+              <a:t> — comando determinístico em torno de um núcleo estocástico</a:t>
             </a:r>
           </a:p>
           <a:p>
@@ -12264,7 +12723,25 @@
                 </a:solidFill>
                 <a:latin typeface="Segoe UI"/>
               </a:rPr>
-              <a:t>—  **Checkpointing** — desfazer o que o agente fez</a:t>
+              <a:t>—  </a:t>
+            </a:r>
+            <a:r>
+              <a:rPr sz="1900" b="1" i="0">
+                <a:solidFill>
+                  <a:srgbClr val="16181D"/>
+                </a:solidFill>
+                <a:latin typeface="Segoe UI"/>
+              </a:rPr>
+              <a:t>Checkpointing</a:t>
+            </a:r>
+            <a:r>
+              <a:rPr sz="1900" b="0" i="0">
+                <a:solidFill>
+                  <a:srgbClr val="16181D"/>
+                </a:solidFill>
+                <a:latin typeface="Segoe UI"/>
+              </a:rPr>
+              <a:t> — desfazer o que o agente fez</a:t>
             </a:r>
           </a:p>
         </p:txBody>
@@ -12651,7 +13128,16 @@
                 </a:solidFill>
                 <a:latin typeface="Segoe UI"/>
               </a:rPr>
-              <a:t>—  **Entender artefato herdado**</a:t>
+              <a:t>—  </a:t>
+            </a:r>
+            <a:r>
+              <a:rPr sz="1900" b="1" i="0">
+                <a:solidFill>
+                  <a:srgbClr val="16181D"/>
+                </a:solidFill>
+                <a:latin typeface="Segoe UI"/>
+              </a:rPr>
+              <a:t>Entender artefato herdado</a:t>
             </a:r>
           </a:p>
           <a:p>
@@ -12717,7 +13203,16 @@
                 </a:solidFill>
                 <a:latin typeface="Segoe UI"/>
               </a:rPr>
-              <a:t>—  **Analisar resultado experimental**</a:t>
+              <a:t>—  </a:t>
+            </a:r>
+            <a:r>
+              <a:rPr sz="1900" b="1" i="0">
+                <a:solidFill>
+                  <a:srgbClr val="16181D"/>
+                </a:solidFill>
+                <a:latin typeface="Segoe UI"/>
+              </a:rPr>
+              <a:t>Analisar resultado experimental</a:t>
             </a:r>
           </a:p>
           <a:p>
@@ -13011,7 +13506,16 @@
                 </a:solidFill>
                 <a:latin typeface="Segoe UI"/>
               </a:rPr>
-              <a:t>—  **Levantar e organizar literatura**</a:t>
+              <a:t>—  </a:t>
+            </a:r>
+            <a:r>
+              <a:rPr sz="1900" b="1" i="0">
+                <a:solidFill>
+                  <a:srgbClr val="16181D"/>
+                </a:solidFill>
+                <a:latin typeface="Segoe UI"/>
+              </a:rPr>
+              <a:t>Levantar e organizar literatura</a:t>
             </a:r>
           </a:p>
           <a:p>
@@ -13077,7 +13581,25 @@
                 </a:solidFill>
                 <a:latin typeface="Segoe UI"/>
               </a:rPr>
-              <a:t>—  **Apoiar a escrita** — estrutura, clareza, revisão de argumento</a:t>
+              <a:t>—  </a:t>
+            </a:r>
+            <a:r>
+              <a:rPr sz="1900" b="1" i="0">
+                <a:solidFill>
+                  <a:srgbClr val="16181D"/>
+                </a:solidFill>
+                <a:latin typeface="Segoe UI"/>
+              </a:rPr>
+              <a:t>Apoiar a escrita</a:t>
+            </a:r>
+            <a:r>
+              <a:rPr sz="1900" b="0" i="0">
+                <a:solidFill>
+                  <a:srgbClr val="16181D"/>
+                </a:solidFill>
+                <a:latin typeface="Segoe UI"/>
+              </a:rPr>
+              <a:t> — estrutura, clareza, revisão de argumento</a:t>
             </a:r>
           </a:p>
           <a:p>
@@ -13099,7 +13621,16 @@
                 </a:solidFill>
                 <a:latin typeface="Segoe UI"/>
               </a:rPr>
-              <a:t>—  Atravessando os quatro: **reprodutibilidade**</a:t>
+              <a:t>—  Atravessando os quatro: </a:t>
+            </a:r>
+            <a:r>
+              <a:rPr sz="1900" b="1" i="0">
+                <a:solidFill>
+                  <a:srgbClr val="16181D"/>
+                </a:solidFill>
+                <a:latin typeface="Segoe UI"/>
+              </a:rPr>
+              <a:t>reprodutibilidade</a:t>
             </a:r>
           </a:p>
           <a:p>
@@ -13415,7 +13946,25 @@
                 </a:solidFill>
                 <a:latin typeface="Segoe UI"/>
               </a:rPr>
-              <a:t>—  **Plan mode**: o agente mostra o plano e espera. Você lê antes de qualquer escrita</a:t>
+              <a:t>—  </a:t>
+            </a:r>
+            <a:r>
+              <a:rPr sz="1900" b="1" i="0">
+                <a:solidFill>
+                  <a:srgbClr val="16181D"/>
+                </a:solidFill>
+                <a:latin typeface="Segoe UI"/>
+              </a:rPr>
+              <a:t>Plan mode</a:t>
+            </a:r>
+            <a:r>
+              <a:rPr sz="1900" b="0" i="0">
+                <a:solidFill>
+                  <a:srgbClr val="16181D"/>
+                </a:solidFill>
+                <a:latin typeface="Segoe UI"/>
+              </a:rPr>
+              <a:t>: o agente mostra o plano e espera. Você lê antes de qualquer escrita</a:t>
             </a:r>
           </a:p>
           <a:p>
@@ -13687,7 +14236,16 @@
                 </a:solidFill>
                 <a:latin typeface="Segoe UI"/>
               </a:rPr>
-              <a:t>—  **Dado técnico**</a:t>
+              <a:t>—  </a:t>
+            </a:r>
+            <a:r>
+              <a:rPr sz="1900" b="1" i="0">
+                <a:solidFill>
+                  <a:srgbClr val="16181D"/>
+                </a:solidFill>
+                <a:latin typeface="Segoe UI"/>
+              </a:rPr>
+              <a:t>Dado técnico</a:t>
             </a:r>
           </a:p>
           <a:p>
@@ -13753,7 +14311,16 @@
                 </a:solidFill>
                 <a:latin typeface="Segoe UI"/>
               </a:rPr>
-              <a:t>—  **Dado de pessoa**</a:t>
+              <a:t>—  </a:t>
+            </a:r>
+            <a:r>
+              <a:rPr sz="1900" b="1" i="0">
+                <a:solidFill>
+                  <a:srgbClr val="16181D"/>
+                </a:solidFill>
+                <a:latin typeface="Segoe UI"/>
+              </a:rPr>
+              <a:t>Dado de pessoa</a:t>
             </a:r>
           </a:p>
           <a:p>
@@ -15380,7 +15947,16 @@
                 </a:solidFill>
                 <a:latin typeface="Segoe UI"/>
               </a:rPr>
-              <a:t>—  Documentação de Agent Skills e do formato `SKILL.md`</a:t>
+              <a:t>—  Documentação de Agent Skills e do formato </a:t>
+            </a:r>
+            <a:r>
+              <a:rPr sz="1748" b="0" i="0">
+                <a:solidFill>
+                  <a:srgbClr val="16181D"/>
+                </a:solidFill>
+                <a:latin typeface="Consolas"/>
+              </a:rPr>
+              <a:t>SKILL.md</a:t>
             </a:r>
           </a:p>
           <a:p>
@@ -15672,8 +16248,8 @@
         </p:blipFill>
         <p:spPr>
           <a:xfrm>
-            <a:off x="1226525" y="1609343"/>
-            <a:ext cx="9738643" cy="4334256"/>
+            <a:off x="1170556" y="1609343"/>
+            <a:ext cx="9850581" cy="4334256"/>
           </a:xfrm>
           <a:prstGeom prst="rect">
             <a:avLst/>
@@ -15688,8 +16264,8 @@
         </p:nvSpPr>
         <p:spPr>
           <a:xfrm>
-            <a:off x="868680" y="5961888"/>
-            <a:ext cx="10454335" cy="274320"/>
+            <a:off x="1170556" y="5998464"/>
+            <a:ext cx="9850581" cy="274320"/>
           </a:xfrm>
           <a:prstGeom prst="rect">
             <a:avLst/>
@@ -15939,7 +16515,7 @@
         <p:spPr>
           <a:xfrm>
             <a:off x="868680" y="1609343"/>
-            <a:ext cx="3744047" cy="4562856"/>
+            <a:ext cx="4162220" cy="4562856"/>
           </a:xfrm>
           <a:prstGeom prst="rect">
             <a:avLst/>
@@ -15992,7 +16568,52 @@
                 </a:solidFill>
                 <a:latin typeface="Segoe UI"/>
               </a:rPr>
-              <a:t>—  É a unidade de **custo**, de **limite** e de **latência**</a:t>
+              <a:t>—  É a unidade de </a:t>
+            </a:r>
+            <a:r>
+              <a:rPr sz="1900" b="1" i="0">
+                <a:solidFill>
+                  <a:srgbClr val="16181D"/>
+                </a:solidFill>
+                <a:latin typeface="Segoe UI"/>
+              </a:rPr>
+              <a:t>custo</a:t>
+            </a:r>
+            <a:r>
+              <a:rPr sz="1900" b="0" i="0">
+                <a:solidFill>
+                  <a:srgbClr val="16181D"/>
+                </a:solidFill>
+                <a:latin typeface="Segoe UI"/>
+              </a:rPr>
+              <a:t>, de </a:t>
+            </a:r>
+            <a:r>
+              <a:rPr sz="1900" b="1" i="0">
+                <a:solidFill>
+                  <a:srgbClr val="16181D"/>
+                </a:solidFill>
+                <a:latin typeface="Segoe UI"/>
+              </a:rPr>
+              <a:t>limite</a:t>
+            </a:r>
+            <a:r>
+              <a:rPr sz="1900" b="0" i="0">
+                <a:solidFill>
+                  <a:srgbClr val="16181D"/>
+                </a:solidFill>
+                <a:latin typeface="Segoe UI"/>
+              </a:rPr>
+              <a:t> e de </a:t>
+            </a:r>
+            <a:r>
+              <a:rPr sz="1900" b="1" i="0">
+                <a:solidFill>
+                  <a:srgbClr val="16181D"/>
+                </a:solidFill>
+                <a:latin typeface="Segoe UI"/>
+              </a:rPr>
+              <a:t>latência</a:t>
             </a:r>
           </a:p>
           <a:p>
@@ -16035,8 +16656,8 @@
         </p:blipFill>
         <p:spPr>
           <a:xfrm>
-            <a:off x="4841327" y="2341344"/>
-            <a:ext cx="6481687" cy="2870254"/>
+            <a:off x="5259500" y="2433933"/>
+            <a:ext cx="6063514" cy="2685076"/>
           </a:xfrm>
           <a:prstGeom prst="rect">
             <a:avLst/>
@@ -16051,8 +16672,8 @@
         </p:nvSpPr>
         <p:spPr>
           <a:xfrm>
-            <a:off x="4841327" y="5961888"/>
-            <a:ext cx="6481687" cy="274320"/>
+            <a:off x="5259500" y="5173874"/>
+            <a:ext cx="6063514" cy="274320"/>
           </a:xfrm>
           <a:prstGeom prst="rect">
             <a:avLst/>
@@ -16663,8 +17284,8 @@
         </p:nvSpPr>
         <p:spPr>
           <a:xfrm>
-            <a:off x="868680" y="5961888"/>
-            <a:ext cx="10454335" cy="274320"/>
+            <a:off x="1050681" y="5998464"/>
+            <a:ext cx="10090331" cy="274320"/>
           </a:xfrm>
           <a:prstGeom prst="rect">
             <a:avLst/>
@@ -16945,7 +17566,25 @@
                 </a:solidFill>
                 <a:latin typeface="Segoe UI"/>
               </a:rPr>
-              <a:t>—  **Pré-treino**: prever texto em larga escala. Produz capacidade bruta</a:t>
+              <a:t>—  </a:t>
+            </a:r>
+            <a:r>
+              <a:rPr sz="1900" b="1" i="0">
+                <a:solidFill>
+                  <a:srgbClr val="16181D"/>
+                </a:solidFill>
+                <a:latin typeface="Segoe UI"/>
+              </a:rPr>
+              <a:t>Pré-treino</a:t>
+            </a:r>
+            <a:r>
+              <a:rPr sz="1900" b="0" i="0">
+                <a:solidFill>
+                  <a:srgbClr val="16181D"/>
+                </a:solidFill>
+                <a:latin typeface="Segoe UI"/>
+              </a:rPr>
+              <a:t>: prever texto em larga escala. Produz capacidade bruta</a:t>
             </a:r>
           </a:p>
           <a:p>
@@ -16967,7 +17606,25 @@
                 </a:solidFill>
                 <a:latin typeface="Segoe UI"/>
               </a:rPr>
-              <a:t>—  **Post-training**: alinhar a modelo de assistente útil e seguro</a:t>
+              <a:t>—  </a:t>
+            </a:r>
+            <a:r>
+              <a:rPr sz="1900" b="1" i="0">
+                <a:solidFill>
+                  <a:srgbClr val="16181D"/>
+                </a:solidFill>
+                <a:latin typeface="Segoe UI"/>
+              </a:rPr>
+              <a:t>Post-training</a:t>
+            </a:r>
+            <a:r>
+              <a:rPr sz="1900" b="0" i="0">
+                <a:solidFill>
+                  <a:srgbClr val="16181D"/>
+                </a:solidFill>
+                <a:latin typeface="Segoe UI"/>
+              </a:rPr>
+              <a:t>: alinhar a modelo de assistente útil e seguro</a:t>
             </a:r>
           </a:p>
           <a:p>
@@ -17033,7 +17690,25 @@
                 </a:solidFill>
                 <a:latin typeface="Segoe UI"/>
               </a:rPr>
-              <a:t>—  **Amostragem e temperatura**: mesmo prompt, saídas diferentes</a:t>
+              <a:t>—  </a:t>
+            </a:r>
+            <a:r>
+              <a:rPr sz="1900" b="1" i="0">
+                <a:solidFill>
+                  <a:srgbClr val="16181D"/>
+                </a:solidFill>
+                <a:latin typeface="Segoe UI"/>
+              </a:rPr>
+              <a:t>Amostragem e temperatura</a:t>
+            </a:r>
+            <a:r>
+              <a:rPr sz="1900" b="0" i="0">
+                <a:solidFill>
+                  <a:srgbClr val="16181D"/>
+                </a:solidFill>
+                <a:latin typeface="Segoe UI"/>
+              </a:rPr>
+              <a:t>: mesmo prompt, saídas diferentes</a:t>
             </a:r>
           </a:p>
           <a:p>

</xml_diff>